<commit_message>
docs: professional-voice pass + de-reference chapter cross-refs
Chapters, READMEs, and the three companion decks:
- Rewrote ~250 narrative 'Chapter N' cross-references to name the concept
  or pattern, so each chapter reads standalone (outline TOC kept intact).
- Voice cleanup: removed hedges/filler, meta-narration, defect/issue-tracker
  framing (e.g. 'What broke' sections reframed as design/operational notes),
  confessional and defensive phrasing, generated-text tells, typographic
  emphasis. Recast em dashes.
- Stripped internal tracking codes (DRQ-*) and iteration labels from
  reader-facing prose.
- Decks: fixed a REST-template leftover in each deck's pres.title, de-referenced
  chapter numbers in notes and captions, recast em dashes; rebuilt all three .pptx.
No code, identifiers, commands, or recorded output changed.
</commit_message>
<xml_diff>
--- a/presentation/websockets-101/WebSockets_101-r1.1.pptx
+++ b/presentation/websockets-101/WebSockets_101-r1.1.pptx
@@ -3551,7 +3551,7 @@
           <a:p>
             <a:r>
               <a:rPr lang="en-US" dirty="0"/>
-              <a:t>A reconnect loop with backoff and jitter solves one problem: the client notices its connection died and gets a new one. It solves nothing about what happened during the gap. A stateless backplane fans an event out to whoever is subscribed right now and forgets it the instant that call returns: a client that disconnects, misses an injected event, and reconnects with a resume parameter finds the event simply gone, not delayed, not buffered, because there was never anywhere to look it up from. A client that cannot tolerate missing events needs a durable, replayable log behind the socket, not a cleverer reconnect loop. A Kafka topic keyed by booking id, carrying only the events injected after the deterministic fixture seed, lets a reconnecting client's resume parameter resolve to either 'replay everything after this id' or 'replay everything the topic has', and either branch is the correct answer, not a fallback apologizing for a limitation. None of this is free: a broker, a consumer group per instance, and a retention policy that bounds how far back a replay can actually reach are real operational cost a stateless design never has to pay.</a:t>
+              <a:t>A reconnect loop with backoff and jitter solves one problem: the client notices its connection died and gets a new one. It solves nothing about what happened during the gap. A stateless backplane fans an event out to whoever is subscribed right now and forgets it the instant that call returns: a client that disconnects, misses an injected event, and reconnects with a resume parameter finds the event simply gone, not delayed, not buffered, because there was never anywhere to look it up from. A client that cannot tolerate missing events needs a durable, replayable log behind the socket, not a cleverer reconnect loop. A Kafka topic keyed by booking id, carrying only the events injected after the deterministic fixture seed, lets a reconnecting client's resume parameter resolve to either 'replay everything after this id' or 'replay everything the topic has', and both are complete, correct answers. None of this is free: a broker, a consumer group per instance, and a retention policy that bounds how far back a replay can actually reach are real operational cost a stateless design never has to pay.</a:t>
             </a:r>
             <a:endParaRPr lang="en-US" dirty="0"/>
           </a:p>
@@ -3639,7 +3639,7 @@
           <a:p>
             <a:r>
               <a:rPr lang="en-US" dirty="0"/>
-              <a:t>A browser's WebSocket constructor cannot attach a custom Authorization header to the opening handshake: a deliberate limitation, not an oversight, because letting arbitrary script attach arbitrary headers to a cross-origin upgrade would reopen exactly the credential-leakage surface CORS exists to close. That pushes a bearer token somewhere else: a query parameter, or the one list the constructor does accept, subprotocols, and either placement ends up in access logs and proxy traces the way a header rarely does, which is why a short token TTL and wss:// are not optional hardening here, they're what makes that trade-off tolerable. Validate the token as the first thing the connection handler does, before a single frame is sent, checking structure, signature, and expiry in that order against a pinned algorithm. Collapse every failure mode, missing, malformed, bad signature, expired, into the identical close code with no detail echoed to the client: a server that answers differently per failure mode hands a prober a signature oracle, two bits of information an attacker can iterate against one guess at a time. The specific reason stays in a server log for an operator, never on the wire.</a:t>
+              <a:t>A browser's WebSocket constructor cannot attach a custom Authorization header to the opening handshake: a deliberate restriction, not an oversight, because letting arbitrary script attach arbitrary headers to a cross-origin upgrade would reopen exactly the credential-leakage surface CORS exists to close. That pushes a bearer token somewhere else: a query parameter, or the one list the constructor does accept, subprotocols, and either placement ends up in access logs and proxy traces the way a header rarely does, which is why a short token TTL and wss:// are not optional hardening here, they're what makes that trade-off tolerable. Validate the token as the first thing the connection handler does, before a single frame is sent, checking structure, signature, and expiry in that order against a pinned algorithm. Collapse every failure mode, missing, malformed, bad signature, expired, into the identical close code with no detail echoed to the client: a server that answers differently per failure mode hands a prober a signature oracle, two bits of information an attacker can iterate against one guess at a time. The specific reason stays in a server log for an operator, never on the wire.</a:t>
             </a:r>
             <a:endParaRPr lang="en-US" dirty="0"/>
           </a:p>
@@ -4343,7 +4343,7 @@
           <a:p>
             <a:r>
               <a:rPr lang="en-US" dirty="0"/>
-              <a:t>Each cost on this slide is a line item this site's own examples paid to keep a long-lived, full-duplex connection correct and operable; none of it hypothetical. Reconnection is application code, not protocol behavior: a reconnect loop solves getting the connection back, not resuming what the gap cost, and fixing that gap took a second backplane mode entirely, with its own topic and its own replay logic. Liveness detection needs its own clock, because the transport's own clock lies: the obvious idle-timeout approach doesn't work, and the real fix is a dedicated scheduled sweep. Backpressure is a hand-rolled guard, not a protocol feature, because a raw WebSocket gives an application nothing here beyond TCP's own flow control. Fan-out across instances needs a backplane and sticky routing, not just more pods. Browser auth gets forced into a query parameter because the handshake has no header slot. Tracing is a hand-written span because the instrumentation mostly doesn't exist yet. None of this argues a socket is wrong everywhere; it argues the decision has to be made the same way every time, for every interaction, rather than defaulted to because the rest of a WebSockets site makes it look obvious.</a:t>
+              <a:t>Each cost on this slide is a line item this site's own examples paid to keep a long-lived, full-duplex connection correct and operable; none of it hypothetical. Reconnection is application code, not protocol behavior: a reconnect loop solves getting the connection back, not resuming what the gap cost, and fixing that gap took a second backplane mode entirely, with its own topic and its own replay logic. Liveness detection needs its own clock, because the transport's own clock lies: the obvious idle-timeout approach doesn't work, and the real fix is a dedicated scheduled sweep. Backpressure is a hand-rolled guard, not a protocol feature, because a raw WebSocket gives an application nothing here beyond TCP's own flow control. Fan-out across instances needs a backplane and sticky routing; more pods alone doesn't solve it. Browser auth gets forced into a query parameter because the handshake has no header slot. Tracing is a hand-written span because the instrumentation mostly doesn't exist yet. None of this argues a socket is wrong everywhere; it argues the decision has to be made the same way every time, for every interaction, rather than defaulted to because the rest of a WebSockets site makes it look obvious.</a:t>
             </a:r>
             <a:endParaRPr lang="en-US" dirty="0"/>
           </a:p>
@@ -8873,7 +8873,7 @@
                 <a:ea typeface="Red Hat Text" pitchFamily="34" charset="-122"/>
                 <a:cs typeface="Red Hat Text" pitchFamily="34" charset="-120"/>
               </a:rPr>
-              <a:t>The real-time problem, and choosing the right transport: not just a socket by default</a:t>
+              <a:t>The real-time problem, and choosing the right transport on the merits, not a socket by default</a:t>
             </a:r>
             <a:endParaRPr lang="en-US" sz="1700" dirty="0"/>
           </a:p>

</xml_diff>

<commit_message>
docs: professional-voice pass + de-reference chapter cross-refs (#24)
Chapters, READMEs, and the three companion decks:
- Rewrote ~250 narrative 'Chapter N' cross-references to name the concept
  or pattern, so each chapter reads standalone (outline TOC kept intact).
- Voice cleanup: removed hedges/filler, meta-narration, defect/issue-tracker
  framing (e.g. 'What broke' sections reframed as design/operational notes),
  confessional and defensive phrasing, generated-text tells, typographic
  emphasis. Recast em dashes.
- Stripped internal tracking codes (DRQ-*) and iteration labels from
  reader-facing prose.
- Decks: fixed a REST-template leftover in each deck's pres.title, de-referenced
  chapter numbers in notes and captions, recast em dashes; rebuilt all three .pptx.
No code, identifiers, commands, or recorded output changed.
</commit_message>
<xml_diff>
--- a/presentation/websockets-101/WebSockets_101-r1.1.pptx
+++ b/presentation/websockets-101/WebSockets_101-r1.1.pptx
@@ -3551,7 +3551,7 @@
           <a:p>
             <a:r>
               <a:rPr lang="en-US" dirty="0"/>
-              <a:t>A reconnect loop with backoff and jitter solves one problem: the client notices its connection died and gets a new one. It solves nothing about what happened during the gap. A stateless backplane fans an event out to whoever is subscribed right now and forgets it the instant that call returns: a client that disconnects, misses an injected event, and reconnects with a resume parameter finds the event simply gone, not delayed, not buffered, because there was never anywhere to look it up from. A client that cannot tolerate missing events needs a durable, replayable log behind the socket, not a cleverer reconnect loop. A Kafka topic keyed by booking id, carrying only the events injected after the deterministic fixture seed, lets a reconnecting client's resume parameter resolve to either 'replay everything after this id' or 'replay everything the topic has', and either branch is the correct answer, not a fallback apologizing for a limitation. None of this is free: a broker, a consumer group per instance, and a retention policy that bounds how far back a replay can actually reach are real operational cost a stateless design never has to pay.</a:t>
+              <a:t>A reconnect loop with backoff and jitter solves one problem: the client notices its connection died and gets a new one. It solves nothing about what happened during the gap. A stateless backplane fans an event out to whoever is subscribed right now and forgets it the instant that call returns: a client that disconnects, misses an injected event, and reconnects with a resume parameter finds the event simply gone, not delayed, not buffered, because there was never anywhere to look it up from. A client that cannot tolerate missing events needs a durable, replayable log behind the socket, not a cleverer reconnect loop. A Kafka topic keyed by booking id, carrying only the events injected after the deterministic fixture seed, lets a reconnecting client's resume parameter resolve to either 'replay everything after this id' or 'replay everything the topic has', and both are complete, correct answers. None of this is free: a broker, a consumer group per instance, and a retention policy that bounds how far back a replay can actually reach are real operational cost a stateless design never has to pay.</a:t>
             </a:r>
             <a:endParaRPr lang="en-US" dirty="0"/>
           </a:p>
@@ -3639,7 +3639,7 @@
           <a:p>
             <a:r>
               <a:rPr lang="en-US" dirty="0"/>
-              <a:t>A browser's WebSocket constructor cannot attach a custom Authorization header to the opening handshake: a deliberate limitation, not an oversight, because letting arbitrary script attach arbitrary headers to a cross-origin upgrade would reopen exactly the credential-leakage surface CORS exists to close. That pushes a bearer token somewhere else: a query parameter, or the one list the constructor does accept, subprotocols, and either placement ends up in access logs and proxy traces the way a header rarely does, which is why a short token TTL and wss:// are not optional hardening here, they're what makes that trade-off tolerable. Validate the token as the first thing the connection handler does, before a single frame is sent, checking structure, signature, and expiry in that order against a pinned algorithm. Collapse every failure mode, missing, malformed, bad signature, expired, into the identical close code with no detail echoed to the client: a server that answers differently per failure mode hands a prober a signature oracle, two bits of information an attacker can iterate against one guess at a time. The specific reason stays in a server log for an operator, never on the wire.</a:t>
+              <a:t>A browser's WebSocket constructor cannot attach a custom Authorization header to the opening handshake: a deliberate restriction, not an oversight, because letting arbitrary script attach arbitrary headers to a cross-origin upgrade would reopen exactly the credential-leakage surface CORS exists to close. That pushes a bearer token somewhere else: a query parameter, or the one list the constructor does accept, subprotocols, and either placement ends up in access logs and proxy traces the way a header rarely does, which is why a short token TTL and wss:// are not optional hardening here, they're what makes that trade-off tolerable. Validate the token as the first thing the connection handler does, before a single frame is sent, checking structure, signature, and expiry in that order against a pinned algorithm. Collapse every failure mode, missing, malformed, bad signature, expired, into the identical close code with no detail echoed to the client: a server that answers differently per failure mode hands a prober a signature oracle, two bits of information an attacker can iterate against one guess at a time. The specific reason stays in a server log for an operator, never on the wire.</a:t>
             </a:r>
             <a:endParaRPr lang="en-US" dirty="0"/>
           </a:p>
@@ -4343,7 +4343,7 @@
           <a:p>
             <a:r>
               <a:rPr lang="en-US" dirty="0"/>
-              <a:t>Each cost on this slide is a line item this site's own examples paid to keep a long-lived, full-duplex connection correct and operable; none of it hypothetical. Reconnection is application code, not protocol behavior: a reconnect loop solves getting the connection back, not resuming what the gap cost, and fixing that gap took a second backplane mode entirely, with its own topic and its own replay logic. Liveness detection needs its own clock, because the transport's own clock lies: the obvious idle-timeout approach doesn't work, and the real fix is a dedicated scheduled sweep. Backpressure is a hand-rolled guard, not a protocol feature, because a raw WebSocket gives an application nothing here beyond TCP's own flow control. Fan-out across instances needs a backplane and sticky routing, not just more pods. Browser auth gets forced into a query parameter because the handshake has no header slot. Tracing is a hand-written span because the instrumentation mostly doesn't exist yet. None of this argues a socket is wrong everywhere; it argues the decision has to be made the same way every time, for every interaction, rather than defaulted to because the rest of a WebSockets site makes it look obvious.</a:t>
+              <a:t>Each cost on this slide is a line item this site's own examples paid to keep a long-lived, full-duplex connection correct and operable; none of it hypothetical. Reconnection is application code, not protocol behavior: a reconnect loop solves getting the connection back, not resuming what the gap cost, and fixing that gap took a second backplane mode entirely, with its own topic and its own replay logic. Liveness detection needs its own clock, because the transport's own clock lies: the obvious idle-timeout approach doesn't work, and the real fix is a dedicated scheduled sweep. Backpressure is a hand-rolled guard, not a protocol feature, because a raw WebSocket gives an application nothing here beyond TCP's own flow control. Fan-out across instances needs a backplane and sticky routing; more pods alone doesn't solve it. Browser auth gets forced into a query parameter because the handshake has no header slot. Tracing is a hand-written span because the instrumentation mostly doesn't exist yet. None of this argues a socket is wrong everywhere; it argues the decision has to be made the same way every time, for every interaction, rather than defaulted to because the rest of a WebSockets site makes it look obvious.</a:t>
             </a:r>
             <a:endParaRPr lang="en-US" dirty="0"/>
           </a:p>
@@ -8873,7 +8873,7 @@
                 <a:ea typeface="Red Hat Text" pitchFamily="34" charset="-122"/>
                 <a:cs typeface="Red Hat Text" pitchFamily="34" charset="-120"/>
               </a:rPr>
-              <a:t>The real-time problem, and choosing the right transport: not just a socket by default</a:t>
+              <a:t>The real-time problem, and choosing the right transport on the merits, not a socket by default</a:t>
             </a:r>
             <a:endParaRPr lang="en-US" sz="1700" dirty="0"/>
           </a:p>

</xml_diff>